<commit_message>
Added code example slides.
</commit_message>
<xml_diff>
--- a/slides/Lecture_Chapter04.pptx
+++ b/slides/Lecture_Chapter04.pptx
@@ -14,10 +14,10 @@
     <p:sldId id="372" r:id="rId8"/>
     <p:sldId id="369" r:id="rId9"/>
     <p:sldId id="370" r:id="rId10"/>
-    <p:sldId id="389" r:id="rId11"/>
-    <p:sldId id="390" r:id="rId12"/>
-    <p:sldId id="371" r:id="rId13"/>
-    <p:sldId id="480" r:id="rId14"/>
+    <p:sldId id="487" r:id="rId11"/>
+    <p:sldId id="389" r:id="rId12"/>
+    <p:sldId id="390" r:id="rId13"/>
+    <p:sldId id="371" r:id="rId14"/>
     <p:sldId id="373" r:id="rId15"/>
     <p:sldId id="375" r:id="rId16"/>
     <p:sldId id="376" r:id="rId17"/>
@@ -25,12 +25,15 @@
     <p:sldId id="378" r:id="rId19"/>
     <p:sldId id="379" r:id="rId20"/>
     <p:sldId id="382" r:id="rId21"/>
-    <p:sldId id="479" r:id="rId22"/>
+    <p:sldId id="486" r:id="rId22"/>
     <p:sldId id="384" r:id="rId23"/>
     <p:sldId id="385" r:id="rId24"/>
-    <p:sldId id="383" r:id="rId25"/>
-    <p:sldId id="386" r:id="rId26"/>
-    <p:sldId id="387" r:id="rId27"/>
+    <p:sldId id="480" r:id="rId25"/>
+    <p:sldId id="488" r:id="rId26"/>
+    <p:sldId id="386" r:id="rId27"/>
+    <p:sldId id="383" r:id="rId28"/>
+    <p:sldId id="489" r:id="rId29"/>
+    <p:sldId id="387" r:id="rId30"/>
   </p:sldIdLst>
   <p:sldSz cx="12192000" cy="6858000"/>
   <p:notesSz cx="6858000" cy="9144000"/>
@@ -151,10 +154,10 @@
             <p14:sldId id="372"/>
             <p14:sldId id="369"/>
             <p14:sldId id="370"/>
+            <p14:sldId id="487"/>
             <p14:sldId id="389"/>
             <p14:sldId id="390"/>
             <p14:sldId id="371"/>
-            <p14:sldId id="480"/>
           </p14:sldIdLst>
         </p14:section>
         <p14:section name="Policy Iteration" id="{4DE153CC-8DA8-4101-A46B-0DFD73F9B57D}">
@@ -170,15 +173,18 @@
             <p14:sldId id="378"/>
             <p14:sldId id="379"/>
             <p14:sldId id="382"/>
-            <p14:sldId id="479"/>
+            <p14:sldId id="486"/>
           </p14:sldIdLst>
         </p14:section>
         <p14:section name="Generalized Policy Iteration" id="{24242526-B5FF-45B4-A80E-CA85C1F5783D}">
           <p14:sldIdLst>
             <p14:sldId id="384"/>
             <p14:sldId id="385"/>
+            <p14:sldId id="480"/>
+            <p14:sldId id="488"/>
+            <p14:sldId id="386"/>
             <p14:sldId id="383"/>
-            <p14:sldId id="386"/>
+            <p14:sldId id="489"/>
           </p14:sldIdLst>
         </p14:section>
         <p14:section name="Summary" id="{6AC1C20A-A1BF-4444-80D7-F422EA17542D}">
@@ -1424,7 +1430,7 @@
           <a:p>
             <a:fld id="{3E22BF2E-04DA-469E-97C5-BB68A0368813}" type="datetimeFigureOut">
               <a:rPr lang="en-US" smtClean="0"/>
-              <a:t>10/22/2026</a:t>
+              <a:t>10/23/2026</a:t>
             </a:fld>
             <a:endParaRPr lang="en-US" dirty="0"/>
           </a:p>
@@ -1622,7 +1628,7 @@
           <a:p>
             <a:fld id="{3E22BF2E-04DA-469E-97C5-BB68A0368813}" type="datetimeFigureOut">
               <a:rPr lang="en-US" smtClean="0"/>
-              <a:t>10/22/2026</a:t>
+              <a:t>10/23/2026</a:t>
             </a:fld>
             <a:endParaRPr lang="en-US" dirty="0"/>
           </a:p>
@@ -1830,7 +1836,7 @@
           <a:p>
             <a:fld id="{3E22BF2E-04DA-469E-97C5-BB68A0368813}" type="datetimeFigureOut">
               <a:rPr lang="en-US" smtClean="0"/>
-              <a:t>10/22/2026</a:t>
+              <a:t>10/23/2026</a:t>
             </a:fld>
             <a:endParaRPr lang="en-US" dirty="0"/>
           </a:p>
@@ -2038,7 +2044,7 @@
           <a:p>
             <a:fld id="{3E22BF2E-04DA-469E-97C5-BB68A0368813}" type="datetimeFigureOut">
               <a:rPr lang="en-US" smtClean="0"/>
-              <a:t>10/22/2026</a:t>
+              <a:t>10/23/2026</a:t>
             </a:fld>
             <a:endParaRPr lang="en-US" dirty="0"/>
           </a:p>
@@ -2313,7 +2319,7 @@
           <a:p>
             <a:fld id="{3E22BF2E-04DA-469E-97C5-BB68A0368813}" type="datetimeFigureOut">
               <a:rPr lang="en-US" smtClean="0"/>
-              <a:t>10/22/2026</a:t>
+              <a:t>10/23/2026</a:t>
             </a:fld>
             <a:endParaRPr lang="en-US" dirty="0"/>
           </a:p>
@@ -2578,7 +2584,7 @@
           <a:p>
             <a:fld id="{3E22BF2E-04DA-469E-97C5-BB68A0368813}" type="datetimeFigureOut">
               <a:rPr lang="en-US" smtClean="0"/>
-              <a:t>10/22/2026</a:t>
+              <a:t>10/23/2026</a:t>
             </a:fld>
             <a:endParaRPr lang="en-US" dirty="0"/>
           </a:p>
@@ -2990,7 +2996,7 @@
           <a:p>
             <a:fld id="{3E22BF2E-04DA-469E-97C5-BB68A0368813}" type="datetimeFigureOut">
               <a:rPr lang="en-US" smtClean="0"/>
-              <a:t>10/22/2026</a:t>
+              <a:t>10/23/2026</a:t>
             </a:fld>
             <a:endParaRPr lang="en-US" dirty="0"/>
           </a:p>
@@ -3131,7 +3137,7 @@
           <a:p>
             <a:fld id="{3E22BF2E-04DA-469E-97C5-BB68A0368813}" type="datetimeFigureOut">
               <a:rPr lang="en-US" smtClean="0"/>
-              <a:t>10/22/2026</a:t>
+              <a:t>10/23/2026</a:t>
             </a:fld>
             <a:endParaRPr lang="en-US" dirty="0"/>
           </a:p>
@@ -3244,7 +3250,7 @@
           <a:p>
             <a:fld id="{3E22BF2E-04DA-469E-97C5-BB68A0368813}" type="datetimeFigureOut">
               <a:rPr lang="en-US" smtClean="0"/>
-              <a:t>10/22/2026</a:t>
+              <a:t>10/23/2026</a:t>
             </a:fld>
             <a:endParaRPr lang="en-US" dirty="0"/>
           </a:p>
@@ -3555,7 +3561,7 @@
           <a:p>
             <a:fld id="{3E22BF2E-04DA-469E-97C5-BB68A0368813}" type="datetimeFigureOut">
               <a:rPr lang="en-US" smtClean="0"/>
-              <a:t>10/22/2026</a:t>
+              <a:t>10/23/2026</a:t>
             </a:fld>
             <a:endParaRPr lang="en-US" dirty="0"/>
           </a:p>
@@ -3843,7 +3849,7 @@
           <a:p>
             <a:fld id="{3E22BF2E-04DA-469E-97C5-BB68A0368813}" type="datetimeFigureOut">
               <a:rPr lang="en-US" smtClean="0"/>
-              <a:t>10/22/2026</a:t>
+              <a:t>10/23/2026</a:t>
             </a:fld>
             <a:endParaRPr lang="en-US" dirty="0"/>
           </a:p>
@@ -4084,7 +4090,7 @@
           <a:p>
             <a:fld id="{3E22BF2E-04DA-469E-97C5-BB68A0368813}" type="datetimeFigureOut">
               <a:rPr lang="en-US" smtClean="0"/>
-              <a:t>10/22/2026</a:t>
+              <a:t>10/23/2026</a:t>
             </a:fld>
             <a:endParaRPr lang="en-US" dirty="0"/>
           </a:p>
@@ -5218,6 +5224,130 @@
 </file>
 
 <file path=ppt/slides/slide10.xml><?xml version="1.0" encoding="utf-8"?>
+<p:sld xmlns:a="http://schemas.openxmlformats.org/drawingml/2006/main" xmlns:r="http://schemas.openxmlformats.org/officeDocument/2006/relationships" xmlns:p="http://schemas.openxmlformats.org/presentationml/2006/main">
+  <p:cSld>
+    <p:spTree>
+      <p:nvGrpSpPr>
+        <p:cNvPr id="1" name="">
+          <a:extLst>
+            <a:ext uri="{FF2B5EF4-FFF2-40B4-BE49-F238E27FC236}">
+              <a16:creationId xmlns:a16="http://schemas.microsoft.com/office/drawing/2014/main" id="{CF2E4B7A-89FE-A1BC-9FBD-EB62A35EA31A}"/>
+            </a:ext>
+          </a:extLst>
+        </p:cNvPr>
+        <p:cNvGrpSpPr/>
+        <p:nvPr/>
+      </p:nvGrpSpPr>
+      <p:grpSpPr>
+        <a:xfrm>
+          <a:off x="0" y="0"/>
+          <a:ext cx="0" cy="0"/>
+          <a:chOff x="0" y="0"/>
+          <a:chExt cx="0" cy="0"/>
+        </a:xfrm>
+      </p:grpSpPr>
+      <p:sp>
+        <p:nvSpPr>
+          <p:cNvPr id="4" name="Title 3">
+            <a:extLst>
+              <a:ext uri="{FF2B5EF4-FFF2-40B4-BE49-F238E27FC236}">
+                <a16:creationId xmlns:a16="http://schemas.microsoft.com/office/drawing/2014/main" id="{C538E76F-A067-CD61-FA3C-C9181A292775}"/>
+              </a:ext>
+            </a:extLst>
+          </p:cNvPr>
+          <p:cNvSpPr>
+            <a:spLocks noGrp="1"/>
+          </p:cNvSpPr>
+          <p:nvPr>
+            <p:ph type="title"/>
+          </p:nvPr>
+        </p:nvSpPr>
+        <p:spPr>
+          <a:xfrm>
+            <a:off x="1105486" y="2766218"/>
+            <a:ext cx="10515600" cy="1168047"/>
+          </a:xfrm>
+        </p:spPr>
+        <p:txBody>
+          <a:bodyPr>
+            <a:normAutofit fontScale="90000"/>
+          </a:bodyPr>
+          <a:lstStyle/>
+          <a:p>
+            <a:r>
+              <a:rPr lang="en-US" b="1" dirty="0"/>
+              <a:t>Code example: </a:t>
+            </a:r>
+            <a:r>
+              <a:rPr lang="en-US" dirty="0"/>
+              <a:t>Policy evaluation for a 2-State MDP as a linear program in Excel.</a:t>
+            </a:r>
+            <a:br>
+              <a:rPr lang="en-US" dirty="0"/>
+            </a:br>
+            <a:endParaRPr lang="en-US" dirty="0"/>
+          </a:p>
+        </p:txBody>
+      </p:sp>
+      <p:sp>
+        <p:nvSpPr>
+          <p:cNvPr id="5" name="TextBox 4">
+            <a:extLst>
+              <a:ext uri="{FF2B5EF4-FFF2-40B4-BE49-F238E27FC236}">
+                <a16:creationId xmlns:a16="http://schemas.microsoft.com/office/drawing/2014/main" id="{708E11EA-CD06-1AFD-B88D-C29C25068BEE}"/>
+              </a:ext>
+            </a:extLst>
+          </p:cNvPr>
+          <p:cNvSpPr txBox="1"/>
+          <p:nvPr/>
+        </p:nvSpPr>
+        <p:spPr>
+          <a:xfrm>
+            <a:off x="1191065" y="6011594"/>
+            <a:ext cx="8811064" cy="307777"/>
+          </a:xfrm>
+          <a:prstGeom prst="rect">
+            <a:avLst/>
+          </a:prstGeom>
+          <a:noFill/>
+        </p:spPr>
+        <p:txBody>
+          <a:bodyPr wrap="square" rtlCol="0">
+            <a:spAutoFit/>
+          </a:bodyPr>
+          <a:lstStyle/>
+          <a:p>
+            <a:r>
+              <a:rPr lang="en-US" sz="1400" dirty="0"/>
+              <a:t>See Code on </a:t>
+            </a:r>
+            <a:r>
+              <a:rPr lang="en-US" sz="1400" dirty="0">
+                <a:hlinkClick r:id="rId2"/>
+              </a:rPr>
+              <a:t>https://michael.hahsler.net/Introduction_to_Reinforcement_Learning/</a:t>
+            </a:r>
+            <a:r>
+              <a:rPr lang="en-US" sz="1400" dirty="0"/>
+              <a:t> </a:t>
+            </a:r>
+          </a:p>
+        </p:txBody>
+      </p:sp>
+    </p:spTree>
+    <p:extLst>
+      <p:ext uri="{BB962C8B-B14F-4D97-AF65-F5344CB8AC3E}">
+        <p14:creationId xmlns:p14="http://schemas.microsoft.com/office/powerpoint/2010/main" val="3111094621"/>
+      </p:ext>
+    </p:extLst>
+  </p:cSld>
+  <p:clrMapOvr>
+    <a:masterClrMapping/>
+  </p:clrMapOvr>
+</p:sld>
+</file>
+
+<file path=ppt/slides/slide11.xml><?xml version="1.0" encoding="utf-8"?>
 <p:sld xmlns:a="http://schemas.openxmlformats.org/drawingml/2006/main" xmlns:r="http://schemas.openxmlformats.org/officeDocument/2006/relationships" xmlns:p="http://schemas.openxmlformats.org/presentationml/2006/main">
   <p:cSld>
     <p:spTree>
@@ -8133,7 +8263,7 @@
 </p:sld>
 </file>
 
-<file path=ppt/slides/slide11.xml><?xml version="1.0" encoding="utf-8"?>
+<file path=ppt/slides/slide12.xml><?xml version="1.0" encoding="utf-8"?>
 <p:sld xmlns:a="http://schemas.openxmlformats.org/drawingml/2006/main" xmlns:r="http://schemas.openxmlformats.org/officeDocument/2006/relationships" xmlns:p="http://schemas.openxmlformats.org/presentationml/2006/main">
   <p:cSld>
     <p:spTree>
@@ -8178,8 +8308,8 @@
           </a:p>
         </p:txBody>
       </p:sp>
-      <mc:AlternateContent xmlns:mc="http://schemas.openxmlformats.org/markup-compatibility/2006">
-        <mc:Choice xmlns:a14="http://schemas.microsoft.com/office/drawing/2010/main" Requires="a14">
+      <mc:AlternateContent xmlns:mc="http://schemas.openxmlformats.org/markup-compatibility/2006" xmlns:a14="http://schemas.microsoft.com/office/drawing/2010/main">
+        <mc:Choice Requires="a14">
           <p:sp>
             <p:nvSpPr>
               <p:cNvPr id="3" name="Content Placeholder 2" descr="The Bellman update can be rewritten as an operator: Bellman Expectation Operator T to the power pi :. (T to the power pi v) (s) equals the sum over a, of pi (a given s) the sum over s prime,r, of p (s prime,r | s,a)[r plus gamma v (s prime)]. The Fixed Point Property: The value function is unchanged if all state values are already consistent. v sub pi equals T to the power pi (v sub pi). The Contraction Property: The operator T to the power pi is gamma -contracting (see textbook for derivation): the norm of T to the power pi u minus T to the power pi v sub infinity is less than or equal to gamma the norm of u minus v sub infinity for any gamma is less than 1 I.e. : Applying T to the power pi reduces the largest difference (infinity norm) between any arbitrary value functions u and v by at least a factor of gamma. This implies: the norm of v sub pi minus T to the power pi v sub infinity is less than or equal to gamma the norm of v sub pi minus v sub infinity for any gamma is less than 1">
@@ -8620,7 +8750,7 @@
             </p:txBody>
           </p:sp>
         </mc:Choice>
-        <mc:Fallback>
+        <mc:Fallback xmlns="">
           <p:sp>
             <p:nvSpPr>
               <p:cNvPr id="3" name="Content Placeholder 2" descr="The Bellman update can be rewritten as an operator: Bellman Expectation Operator T to the power pi :. (T to the power pi v) (s) equals the sum over a, of pi (a given s) the sum over s prime,r, of p (s prime,r | s,a)[r plus gamma v (s prime)]. The Fixed Point Property: The value function is unchanged if all state values are already consistent. v sub pi equals T to the power pi (v sub pi). The Contraction Property: The operator T to the power pi is gamma -contracting (see textbook for derivation): the norm of T to the power pi u minus T to the power pi v sub infinity is less than or equal to gamma the norm of u minus v sub infinity for any gamma is less than 1 I.e. : Applying T to the power pi reduces the largest difference (infinity norm) between any arbitrary value functions u and v by at least a factor of gamma. This implies: the norm of v sub pi minus T to the power pi v sub infinity is less than or equal to gamma the norm of v sub pi minus v sub infinity for any gamma is less than 1">
@@ -8664,8 +8794,8 @@
           </p:sp>
         </mc:Fallback>
       </mc:AlternateContent>
-      <mc:AlternateContent xmlns:mc="http://schemas.openxmlformats.org/markup-compatibility/2006">
-        <mc:Choice xmlns:a14="http://schemas.microsoft.com/office/drawing/2010/main" Requires="a14">
+      <mc:AlternateContent xmlns:mc="http://schemas.openxmlformats.org/markup-compatibility/2006" xmlns:a14="http://schemas.microsoft.com/office/drawing/2010/main">
+        <mc:Choice Requires="a14">
           <p:sp>
             <p:nvSpPr>
               <p:cNvPr id="5" name="Speech Bubble: Rectangle with Corners Rounded 4" descr="Convergence if gamma is less than 1 : T to the power pi T to the power pi T to the power pi dot dot dot T to the power pi v to v sub pi for any v">
@@ -8905,7 +9035,7 @@
             </p:txBody>
           </p:sp>
         </mc:Choice>
-        <mc:Fallback>
+        <mc:Fallback xmlns="">
           <p:sp>
             <p:nvSpPr>
               <p:cNvPr id="5" name="Speech Bubble: Rectangle with Corners Rounded 4" descr="Convergence if gamma is less than 1 : T to the power pi T to the power pi T to the power pi dot dot dot T to the power pi v to v sub pi for any v">
@@ -8954,8 +9084,8 @@
           </p:sp>
         </mc:Fallback>
       </mc:AlternateContent>
-      <mc:AlternateContent xmlns:mc="http://schemas.openxmlformats.org/markup-compatibility/2006">
-        <mc:Choice xmlns:a14="http://schemas.microsoft.com/office/drawing/2010/main" Requires="a14">
+      <mc:AlternateContent xmlns:mc="http://schemas.openxmlformats.org/markup-compatibility/2006" xmlns:a14="http://schemas.microsoft.com/office/drawing/2010/main">
+        <mc:Choice Requires="a14">
           <p:sp>
             <p:nvSpPr>
               <p:cNvPr id="6" name="TextBox 5" descr="Notation:. (T to the power pi v) is the new value function after applying the operator. We could write v sub k plus 1, equals T to the power pi (v sub k)">
@@ -9161,7 +9291,7 @@
             </p:txBody>
           </p:sp>
         </mc:Choice>
-        <mc:Fallback>
+        <mc:Fallback xmlns="">
           <p:sp>
             <p:nvSpPr>
               <p:cNvPr id="6" name="TextBox 5" descr="Notation:. (T to the power pi v) is the new value function after applying the operator. We could write v sub k plus 1, equals T to the power pi (v sub k)">
@@ -11299,8 +11429,8 @@
           </mc:Fallback>
         </mc:AlternateContent>
       </p:grpSp>
-      <mc:AlternateContent xmlns:mc="http://schemas.openxmlformats.org/markup-compatibility/2006">
-        <mc:Choice xmlns:a14="http://schemas.microsoft.com/office/drawing/2010/main" Requires="a14">
+      <mc:AlternateContent xmlns:mc="http://schemas.openxmlformats.org/markup-compatibility/2006" xmlns:a14="http://schemas.microsoft.com/office/drawing/2010/main">
+        <mc:Choice Requires="a14">
           <p:sp>
             <p:nvSpPr>
               <p:cNvPr id="7" name="TextBox 6">
@@ -11464,7 +11594,7 @@
             </p:txBody>
           </p:sp>
         </mc:Choice>
-        <mc:Fallback>
+        <mc:Fallback xmlns="">
           <p:sp>
             <p:nvSpPr>
               <p:cNvPr id="7" name="TextBox 6">
@@ -11509,8 +11639,8 @@
           </p:sp>
         </mc:Fallback>
       </mc:AlternateContent>
-      <mc:AlternateContent xmlns:mc="http://schemas.openxmlformats.org/markup-compatibility/2006">
-        <mc:Choice xmlns:a14="http://schemas.microsoft.com/office/drawing/2010/main" Requires="a14">
+      <mc:AlternateContent xmlns:mc="http://schemas.openxmlformats.org/markup-compatibility/2006" xmlns:a14="http://schemas.microsoft.com/office/drawing/2010/main">
+        <mc:Choice Requires="a14">
           <p:sp>
             <p:nvSpPr>
               <p:cNvPr id="24" name="TextBox 23">
@@ -11911,7 +12041,7 @@
             </p:txBody>
           </p:sp>
         </mc:Choice>
-        <mc:Fallback>
+        <mc:Fallback xmlns="">
           <p:sp>
             <p:nvSpPr>
               <p:cNvPr id="24" name="TextBox 23">
@@ -11956,8 +12086,8 @@
           </p:sp>
         </mc:Fallback>
       </mc:AlternateContent>
-      <mc:AlternateContent xmlns:mc="http://schemas.openxmlformats.org/markup-compatibility/2006">
-        <mc:Choice xmlns:a14="http://schemas.microsoft.com/office/drawing/2010/main" Requires="a14">
+      <mc:AlternateContent xmlns:mc="http://schemas.openxmlformats.org/markup-compatibility/2006" xmlns:a14="http://schemas.microsoft.com/office/drawing/2010/main">
+        <mc:Choice Requires="a14">
           <p:sp>
             <p:nvSpPr>
               <p:cNvPr id="29" name="TextBox 28">
@@ -12201,7 +12331,7 @@
             </p:txBody>
           </p:sp>
         </mc:Choice>
-        <mc:Fallback>
+        <mc:Fallback xmlns="">
           <p:sp>
             <p:nvSpPr>
               <p:cNvPr id="29" name="TextBox 28">
@@ -12502,7 +12632,7 @@
 </p:sld>
 </file>
 
-<file path=ppt/slides/slide12.xml><?xml version="1.0" encoding="utf-8"?>
+<file path=ppt/slides/slide13.xml><?xml version="1.0" encoding="utf-8"?>
 <p:sld xmlns:a="http://schemas.openxmlformats.org/drawingml/2006/main" xmlns:r="http://schemas.openxmlformats.org/officeDocument/2006/relationships" xmlns:p="http://schemas.openxmlformats.org/presentationml/2006/main">
   <p:cSld>
     <p:spTree>
@@ -13635,222 +13765,6 @@
       <p:bldP spid="8" grpId="0" animBg="1"/>
     </p:bldLst>
   </p:timing>
-</p:sld>
-</file>
-
-<file path=ppt/slides/slide13.xml><?xml version="1.0" encoding="utf-8"?>
-<p:sld xmlns:a="http://schemas.openxmlformats.org/drawingml/2006/main" xmlns:r="http://schemas.openxmlformats.org/officeDocument/2006/relationships" xmlns:p="http://schemas.openxmlformats.org/presentationml/2006/main">
-  <p:cSld>
-    <p:spTree>
-      <p:nvGrpSpPr>
-        <p:cNvPr id="1" name=""/>
-        <p:cNvGrpSpPr/>
-        <p:nvPr/>
-      </p:nvGrpSpPr>
-      <p:grpSpPr>
-        <a:xfrm>
-          <a:off x="0" y="0"/>
-          <a:ext cx="0" cy="0"/>
-          <a:chOff x="0" y="0"/>
-          <a:chExt cx="0" cy="0"/>
-        </a:xfrm>
-      </p:grpSpPr>
-      <p:sp>
-        <p:nvSpPr>
-          <p:cNvPr id="2" name="Title 1">
-            <a:extLst>
-              <a:ext uri="{FF2B5EF4-FFF2-40B4-BE49-F238E27FC236}">
-                <a16:creationId xmlns:a16="http://schemas.microsoft.com/office/drawing/2014/main" id="{63AB4F15-1BAA-E34A-C756-20976A500CB1}"/>
-              </a:ext>
-            </a:extLst>
-          </p:cNvPr>
-          <p:cNvSpPr>
-            <a:spLocks noGrp="1"/>
-          </p:cNvSpPr>
-          <p:nvPr>
-            <p:ph type="title"/>
-          </p:nvPr>
-        </p:nvSpPr>
-        <p:spPr/>
-        <p:txBody>
-          <a:bodyPr/>
-          <a:lstStyle/>
-          <a:p>
-            <a:r>
-              <a:rPr lang="en-US" dirty="0"/>
-              <a:t>More on Convergence</a:t>
-            </a:r>
-          </a:p>
-        </p:txBody>
-      </p:sp>
-      <mc:AlternateContent xmlns:mc="http://schemas.openxmlformats.org/markup-compatibility/2006">
-        <mc:Choice xmlns:a14="http://schemas.microsoft.com/office/drawing/2010/main" Requires="a14">
-          <p:sp>
-            <p:nvSpPr>
-              <p:cNvPr id="3" name="Content Placeholder 2">
-                <a:extLst>
-                  <a:ext uri="{FF2B5EF4-FFF2-40B4-BE49-F238E27FC236}">
-                    <a16:creationId xmlns:a16="http://schemas.microsoft.com/office/drawing/2014/main" id="{B19B88DF-BBBD-581D-8BC9-011B1D14AED2}"/>
-                  </a:ext>
-                </a:extLst>
-              </p:cNvPr>
-              <p:cNvSpPr>
-                <a:spLocks noGrp="1"/>
-              </p:cNvSpPr>
-              <p:nvPr>
-                <p:ph idx="1"/>
-              </p:nvPr>
-            </p:nvSpPr>
-            <p:spPr/>
-            <p:txBody>
-              <a:bodyPr>
-                <a:normAutofit/>
-              </a:bodyPr>
-              <a:lstStyle/>
-              <a:p>
-                <a:pPr marL="0" indent="0">
-                  <a:buNone/>
-                </a:pPr>
-                <a:r>
-                  <a:rPr lang="en-US" dirty="0"/>
-                  <a:t>Policy evaluation and all algorithms built on the idea always converge for:</a:t>
-                </a:r>
-              </a:p>
-              <a:p>
-                <a:pPr marL="0" indent="0">
-                  <a:buNone/>
-                </a:pPr>
-                <a:endParaRPr lang="en-US" dirty="0"/>
-              </a:p>
-              <a:p>
-                <a:pPr marL="514350" indent="-514350">
-                  <a:buFont typeface="+mj-lt"/>
-                  <a:buAutoNum type="arabicPeriod"/>
-                </a:pPr>
-                <a:r>
-                  <a:rPr lang="en-US" b="0" dirty="0"/>
-                  <a:t> </a:t>
-                </a:r>
-                <a14:m>
-                  <m:oMath xmlns:m="http://schemas.openxmlformats.org/officeDocument/2006/math">
-                    <m:r>
-                      <a:rPr lang="en-US" b="0" i="1" smtClean="0">
-                        <a:latin typeface="Cambria Math" panose="02040503050406030204" pitchFamily="18" charset="0"/>
-                      </a:rPr>
-                      <m:t>𝛾</m:t>
-                    </m:r>
-                    <m:r>
-                      <a:rPr lang="en-US" b="0" i="1" smtClean="0">
-                        <a:latin typeface="Cambria Math" panose="02040503050406030204" pitchFamily="18" charset="0"/>
-                      </a:rPr>
-                      <m:t>&lt;1</m:t>
-                    </m:r>
-                  </m:oMath>
-                </a14:m>
-                <a:r>
-                  <a:rPr lang="en-US" b="0" dirty="0"/>
-                  <a:t> </a:t>
-                </a:r>
-              </a:p>
-              <a:p>
-                <a:pPr marL="514350" indent="-514350">
-                  <a:buFont typeface="+mj-lt"/>
-                  <a:buAutoNum type="arabicPeriod"/>
-                </a:pPr>
-                <a:r>
-                  <a:rPr lang="en-US" dirty="0"/>
-                  <a:t> </a:t>
-                </a:r>
-                <a14:m>
-                  <m:oMath xmlns:m="http://schemas.openxmlformats.org/officeDocument/2006/math">
-                    <m:r>
-                      <a:rPr lang="en-US" b="0" i="1" smtClean="0">
-                        <a:latin typeface="Cambria Math" panose="02040503050406030204" pitchFamily="18" charset="0"/>
-                      </a:rPr>
-                      <m:t>𝛾</m:t>
-                    </m:r>
-                    <m:r>
-                      <a:rPr lang="en-US" b="0" i="1" smtClean="0">
-                        <a:latin typeface="Cambria Math" panose="02040503050406030204" pitchFamily="18" charset="0"/>
-                      </a:rPr>
-                      <m:t>=1</m:t>
-                    </m:r>
-                  </m:oMath>
-                </a14:m>
-                <a:r>
-                  <a:rPr lang="en-US" dirty="0"/>
-                  <a:t> and a terminating policy*</a:t>
-                </a:r>
-              </a:p>
-              <a:p>
-                <a:pPr marL="514350" indent="-514350">
-                  <a:buFont typeface="+mj-lt"/>
-                  <a:buAutoNum type="arabicPeriod"/>
-                </a:pPr>
-                <a:endParaRPr lang="en-US" dirty="0"/>
-              </a:p>
-              <a:p>
-                <a:pPr marL="0" indent="0">
-                  <a:buNone/>
-                </a:pPr>
-                <a:r>
-                  <a:rPr lang="en-US" sz="2400" dirty="0"/>
-                  <a:t>* The evaluated policy must always reach a terminating state to end the episode.</a:t>
-                </a:r>
-              </a:p>
-            </p:txBody>
-          </p:sp>
-        </mc:Choice>
-        <mc:Fallback>
-          <p:sp>
-            <p:nvSpPr>
-              <p:cNvPr id="3" name="Content Placeholder 2">
-                <a:extLst>
-                  <a:ext uri="{FF2B5EF4-FFF2-40B4-BE49-F238E27FC236}">
-                    <a16:creationId xmlns:a16="http://schemas.microsoft.com/office/drawing/2014/main" id="{B19B88DF-BBBD-581D-8BC9-011B1D14AED2}"/>
-                  </a:ext>
-                </a:extLst>
-              </p:cNvPr>
-              <p:cNvSpPr>
-                <a:spLocks noGrp="1" noRot="1" noChangeAspect="1" noMove="1" noResize="1" noEditPoints="1" noAdjustHandles="1" noChangeArrowheads="1" noChangeShapeType="1" noTextEdit="1"/>
-              </p:cNvSpPr>
-              <p:nvPr>
-                <p:ph idx="1"/>
-              </p:nvPr>
-            </p:nvSpPr>
-            <p:spPr>
-              <a:blipFill>
-                <a:blip r:embed="rId2"/>
-                <a:stretch>
-                  <a:fillRect l="-1217" t="-2168"/>
-                </a:stretch>
-              </a:blipFill>
-            </p:spPr>
-            <p:txBody>
-              <a:bodyPr/>
-              <a:lstStyle/>
-              <a:p>
-                <a:r>
-                  <a:rPr lang="en-US">
-                    <a:noFill/>
-                  </a:rPr>
-                  <a:t> </a:t>
-                </a:r>
-              </a:p>
-            </p:txBody>
-          </p:sp>
-        </mc:Fallback>
-      </mc:AlternateContent>
-    </p:spTree>
-    <p:extLst>
-      <p:ext uri="{BB962C8B-B14F-4D97-AF65-F5344CB8AC3E}">
-        <p14:creationId xmlns:p14="http://schemas.microsoft.com/office/powerpoint/2010/main" val="4156439938"/>
-      </p:ext>
-    </p:extLst>
-  </p:cSld>
-  <p:clrMapOvr>
-    <a:masterClrMapping/>
-  </p:clrMapOvr>
 </p:sld>
 </file>
 
@@ -23706,7 +23620,7 @@
           <p:cNvPr id="4" name="Title 3">
             <a:extLst>
               <a:ext uri="{FF2B5EF4-FFF2-40B4-BE49-F238E27FC236}">
-                <a16:creationId xmlns:a16="http://schemas.microsoft.com/office/drawing/2014/main" id="{0930CFB0-D2B7-437F-8981-207DBA2A813F}"/>
+                <a16:creationId xmlns:a16="http://schemas.microsoft.com/office/drawing/2014/main" id="{24CD2877-1046-6123-CF1E-BE9F2D8536CB}"/>
               </a:ext>
             </a:extLst>
           </p:cNvPr>
@@ -23717,50 +23631,82 @@
             <p:ph type="title"/>
           </p:nvPr>
         </p:nvSpPr>
-        <p:spPr/>
+        <p:spPr>
+          <a:xfrm>
+            <a:off x="1105486" y="2766218"/>
+            <a:ext cx="10515600" cy="1168047"/>
+          </a:xfrm>
+        </p:spPr>
         <p:txBody>
-          <a:bodyPr/>
+          <a:bodyPr>
+            <a:normAutofit fontScale="90000"/>
+          </a:bodyPr>
           <a:lstStyle/>
           <a:p>
             <a:r>
+              <a:rPr lang="en-US" b="1" dirty="0"/>
+              <a:t>Code example: </a:t>
+            </a:r>
+            <a:r>
               <a:rPr lang="en-US" dirty="0"/>
-              <a:t>Code…</a:t>
+              <a:t>Algorithm Implementation (Policy and Value Iteration)</a:t>
             </a:r>
+            <a:br>
+              <a:rPr lang="en-US" dirty="0"/>
+            </a:br>
+            <a:endParaRPr lang="en-US" dirty="0"/>
           </a:p>
         </p:txBody>
       </p:sp>
       <p:sp>
         <p:nvSpPr>
-          <p:cNvPr id="5" name="Text Placeholder 4">
+          <p:cNvPr id="5" name="TextBox 4">
             <a:extLst>
               <a:ext uri="{FF2B5EF4-FFF2-40B4-BE49-F238E27FC236}">
-                <a16:creationId xmlns:a16="http://schemas.microsoft.com/office/drawing/2014/main" id="{6BF9353D-E2F6-5C2D-E559-4D7DA584DF5F}"/>
-              </a:ext>
-              <a:ext uri="{C183D7F6-B498-43B3-948B-1728B52AA6E4}">
-                <adec:decorative xmlns:adec="http://schemas.microsoft.com/office/drawing/2017/decorative" val="1"/>
+                <a16:creationId xmlns:a16="http://schemas.microsoft.com/office/drawing/2014/main" id="{5AA484FF-058C-4694-424C-0B3B26DF9F45}"/>
               </a:ext>
             </a:extLst>
           </p:cNvPr>
-          <p:cNvSpPr>
-            <a:spLocks noGrp="1"/>
-          </p:cNvSpPr>
-          <p:nvPr>
-            <p:ph type="body" idx="1"/>
-          </p:nvPr>
+          <p:cNvSpPr txBox="1"/>
+          <p:nvPr/>
         </p:nvSpPr>
-        <p:spPr/>
+        <p:spPr>
+          <a:xfrm>
+            <a:off x="1191065" y="6011594"/>
+            <a:ext cx="8811064" cy="307777"/>
+          </a:xfrm>
+          <a:prstGeom prst="rect">
+            <a:avLst/>
+          </a:prstGeom>
+          <a:noFill/>
+        </p:spPr>
         <p:txBody>
-          <a:bodyPr/>
+          <a:bodyPr wrap="square" rtlCol="0">
+            <a:spAutoFit/>
+          </a:bodyPr>
           <a:lstStyle/>
           <a:p>
-            <a:endParaRPr lang="en-US" dirty="0"/>
+            <a:r>
+              <a:rPr lang="en-US" sz="1400" dirty="0"/>
+              <a:t>See Code on </a:t>
+            </a:r>
+            <a:r>
+              <a:rPr lang="en-US" sz="1400" dirty="0">
+                <a:hlinkClick r:id="rId2"/>
+              </a:rPr>
+              <a:t>https://michael.hahsler.net/Introduction_to_Reinforcement_Learning/</a:t>
+            </a:r>
+            <a:r>
+              <a:rPr lang="en-US" sz="1400" dirty="0"/>
+              <a:t> </a:t>
+            </a:r>
           </a:p>
         </p:txBody>
       </p:sp>
     </p:spTree>
     <p:extLst>
       <p:ext uri="{BB962C8B-B14F-4D97-AF65-F5344CB8AC3E}">
-        <p14:creationId xmlns:p14="http://schemas.microsoft.com/office/powerpoint/2010/main" val="4164509424"/>
+        <p14:creationId xmlns:p14="http://schemas.microsoft.com/office/powerpoint/2010/main" val="190193640"/>
       </p:ext>
     </p:extLst>
   </p:cSld>
@@ -24245,7 +24191,7 @@
           <p:cNvPr id="2" name="Title 1">
             <a:extLst>
               <a:ext uri="{FF2B5EF4-FFF2-40B4-BE49-F238E27FC236}">
-                <a16:creationId xmlns:a16="http://schemas.microsoft.com/office/drawing/2014/main" id="{CE64B189-2BE7-EF8E-90AD-B8D2A5B4A30A}"/>
+                <a16:creationId xmlns:a16="http://schemas.microsoft.com/office/drawing/2014/main" id="{63AB4F15-1BAA-E34A-C756-20976A500CB1}"/>
               </a:ext>
             </a:extLst>
           </p:cNvPr>
@@ -24263,7 +24209,7 @@
           <a:p>
             <a:r>
               <a:rPr lang="en-US" dirty="0"/>
-              <a:t>Issues with DP Methods</a:t>
+              <a:t>More on Convergence</a:t>
             </a:r>
           </a:p>
         </p:txBody>
@@ -24272,10 +24218,10 @@
         <mc:Choice Requires="a14">
           <p:sp>
             <p:nvSpPr>
-              <p:cNvPr id="3" name="Content Placeholder 2" descr="Require perfect knowledge of the model!. Space Complexity. Tabular method: stores the complete value function as tables V or Q . Time Complexity. Updates repeatedly sweep over the whole state space. Wastes computation by updating states that are not relevant for the optimal behavior. I.e., the optimal policy will never visit them. Tabular methods can not generalize between similar states">
+              <p:cNvPr id="3" name="Content Placeholder 2">
                 <a:extLst>
                   <a:ext uri="{FF2B5EF4-FFF2-40B4-BE49-F238E27FC236}">
-                    <a16:creationId xmlns:a16="http://schemas.microsoft.com/office/drawing/2014/main" id="{5664E2E2-C328-F2E5-08B7-7436CBE7F52E}"/>
+                    <a16:creationId xmlns:a16="http://schemas.microsoft.com/office/drawing/2014/main" id="{B19B88DF-BBBD-581D-8BC9-011B1D14AED2}"/>
                   </a:ext>
                 </a:extLst>
               </p:cNvPr>
@@ -24286,15 +24232,10 @@
                 <p:ph idx="1"/>
               </p:nvPr>
             </p:nvSpPr>
-            <p:spPr>
-              <a:xfrm>
-                <a:off x="838200" y="1397330"/>
-                <a:ext cx="8804945" cy="4779633"/>
-              </a:xfrm>
-            </p:spPr>
+            <p:spPr/>
             <p:txBody>
               <a:bodyPr>
-                <a:normAutofit lnSpcReduction="10000"/>
+                <a:normAutofit/>
               </a:bodyPr>
               <a:lstStyle/>
               <a:p>
@@ -24302,31 +24243,24 @@
                   <a:buNone/>
                 </a:pPr>
                 <a:r>
-                  <a:rPr lang="en-US" b="1" dirty="0"/>
-                  <a:t>Require perfect knowledge of the model!</a:t>
+                  <a:rPr lang="en-US" dirty="0"/>
+                  <a:t>Policy evaluation and all algorithms built on the idea always converge for:</a:t>
                 </a:r>
               </a:p>
               <a:p>
                 <a:pPr marL="0" indent="0">
                   <a:buNone/>
                 </a:pPr>
-                <a:endParaRPr lang="en-US" b="1" dirty="0"/>
-              </a:p>
-              <a:p>
-                <a:pPr marL="0" indent="0">
-                  <a:buNone/>
-                </a:pPr>
-                <a:r>
-                  <a:rPr lang="en-US" b="1" dirty="0"/>
-                  <a:t>Space Complexity</a:t>
-                </a:r>
                 <a:endParaRPr lang="en-US" dirty="0"/>
               </a:p>
               <a:p>
-                <a:pPr lvl="1"/>
+                <a:pPr marL="514350" indent="-514350">
+                  <a:buFont typeface="+mj-lt"/>
+                  <a:buAutoNum type="arabicPeriod"/>
+                </a:pPr>
                 <a:r>
-                  <a:rPr lang="en-US" dirty="0"/>
-                  <a:t>Tabular method: stores the complete value function as tables </a:t>
+                  <a:rPr lang="en-US" b="0" dirty="0"/>
+                  <a:t> </a:t>
                 </a:r>
                 <a14:m>
                   <m:oMath xmlns:m="http://schemas.openxmlformats.org/officeDocument/2006/math">
@@ -24334,13 +24268,29 @@
                       <a:rPr lang="en-US" b="0" i="1" smtClean="0">
                         <a:latin typeface="Cambria Math" panose="02040503050406030204" pitchFamily="18" charset="0"/>
                       </a:rPr>
-                      <m:t>𝑉</m:t>
+                      <m:t>𝛾</m:t>
+                    </m:r>
+                    <m:r>
+                      <a:rPr lang="en-US" b="0" i="1" smtClean="0">
+                        <a:latin typeface="Cambria Math" panose="02040503050406030204" pitchFamily="18" charset="0"/>
+                      </a:rPr>
+                      <m:t>&lt;1</m:t>
                     </m:r>
                   </m:oMath>
                 </a14:m>
                 <a:r>
+                  <a:rPr lang="en-US" b="0" dirty="0"/>
+                  <a:t> </a:t>
+                </a:r>
+              </a:p>
+              <a:p>
+                <a:pPr marL="514350" indent="-514350">
+                  <a:buFont typeface="+mj-lt"/>
+                  <a:buAutoNum type="arabicPeriod"/>
+                </a:pPr>
+                <a:r>
                   <a:rPr lang="en-US" dirty="0"/>
-                  <a:t> or </a:t>
+                  <a:t> </a:t>
                 </a:r>
                 <a14:m>
                   <m:oMath xmlns:m="http://schemas.openxmlformats.org/officeDocument/2006/math">
@@ -24348,16 +24298,26 @@
                       <a:rPr lang="en-US" b="0" i="1" smtClean="0">
                         <a:latin typeface="Cambria Math" panose="02040503050406030204" pitchFamily="18" charset="0"/>
                       </a:rPr>
-                      <m:t>𝑄</m:t>
+                      <m:t>𝛾</m:t>
+                    </m:r>
+                    <m:r>
+                      <a:rPr lang="en-US" b="0" i="1" smtClean="0">
+                        <a:latin typeface="Cambria Math" panose="02040503050406030204" pitchFamily="18" charset="0"/>
+                      </a:rPr>
+                      <m:t>=1</m:t>
                     </m:r>
                   </m:oMath>
                 </a14:m>
                 <a:r>
                   <a:rPr lang="en-US" dirty="0"/>
-                  <a:t>. </a:t>
+                  <a:t> and a terminating policy*</a:t>
                 </a:r>
               </a:p>
               <a:p>
+                <a:pPr marL="514350" indent="-514350">
+                  <a:buFont typeface="+mj-lt"/>
+                  <a:buAutoNum type="arabicPeriod"/>
+                </a:pPr>
                 <a:endParaRPr lang="en-US" dirty="0"/>
               </a:p>
               <a:p>
@@ -24365,29 +24325,8 @@
                   <a:buNone/>
                 </a:pPr>
                 <a:r>
-                  <a:rPr lang="en-US" b="1" dirty="0"/>
-                  <a:t>Time Complexity</a:t>
-                </a:r>
-              </a:p>
-              <a:p>
-                <a:pPr lvl="1"/>
-                <a:r>
-                  <a:rPr lang="en-US" dirty="0"/>
-                  <a:t>Updates repeatedly sweep over the whole state space.</a:t>
-                </a:r>
-              </a:p>
-              <a:p>
-                <a:pPr lvl="1"/>
-                <a:r>
-                  <a:rPr lang="en-US" dirty="0"/>
-                  <a:t>Wastes computation by updating states that are not relevant for the optimal behavior. I.e., the optimal policy will never visit them.</a:t>
-                </a:r>
-              </a:p>
-              <a:p>
-                <a:pPr lvl="1"/>
-                <a:r>
-                  <a:rPr lang="en-US" dirty="0"/>
-                  <a:t>Tabular methods can not generalize between similar states.</a:t>
+                  <a:rPr lang="en-US" sz="2400" dirty="0"/>
+                  <a:t>* The evaluated policy must always reach a terminating state to end the episode.</a:t>
                 </a:r>
               </a:p>
             </p:txBody>
@@ -24396,10 +24335,10 @@
         <mc:Fallback xmlns="">
           <p:sp>
             <p:nvSpPr>
-              <p:cNvPr id="3" name="Content Placeholder 2" descr="Require perfect knowledge of the model!. Space Complexity. Tabular method: stores the complete value function as tables V or Q . Time Complexity. Updates repeatedly sweep over the whole state space. Wastes computation by updating states that are not relevant for the optimal behavior. I.e., the optimal policy will never visit them. Tabular methods can not generalize between similar states">
+              <p:cNvPr id="3" name="Content Placeholder 2">
                 <a:extLst>
                   <a:ext uri="{FF2B5EF4-FFF2-40B4-BE49-F238E27FC236}">
-                    <a16:creationId xmlns:a16="http://schemas.microsoft.com/office/drawing/2014/main" id="{5664E2E2-C328-F2E5-08B7-7436CBE7F52E}"/>
+                    <a16:creationId xmlns:a16="http://schemas.microsoft.com/office/drawing/2014/main" id="{B19B88DF-BBBD-581D-8BC9-011B1D14AED2}"/>
                   </a:ext>
                 </a:extLst>
               </p:cNvPr>
@@ -24411,14 +24350,10 @@
               </p:nvPr>
             </p:nvSpPr>
             <p:spPr>
-              <a:xfrm>
-                <a:off x="838200" y="1397330"/>
-                <a:ext cx="8804945" cy="4779633"/>
-              </a:xfrm>
               <a:blipFill>
                 <a:blip r:embed="rId2"/>
                 <a:stretch>
-                  <a:fillRect l="-1454" t="-2806" r="-1108"/>
+                  <a:fillRect l="-1217" t="-2168"/>
                 </a:stretch>
               </a:blipFill>
             </p:spPr>
@@ -24437,107 +24372,10 @@
           </p:sp>
         </mc:Fallback>
       </mc:AlternateContent>
-      <p:sp>
-        <p:nvSpPr>
-          <p:cNvPr id="4" name="Right Brace 3">
-            <a:extLst>
-              <a:ext uri="{FF2B5EF4-FFF2-40B4-BE49-F238E27FC236}">
-                <a16:creationId xmlns:a16="http://schemas.microsoft.com/office/drawing/2014/main" id="{6339C8F8-48C4-0C07-3B0E-F41FE0B782D3}"/>
-              </a:ext>
-              <a:ext uri="{C183D7F6-B498-43B3-948B-1728B52AA6E4}">
-                <adec:decorative xmlns:adec="http://schemas.microsoft.com/office/drawing/2017/decorative" val="1"/>
-              </a:ext>
-            </a:extLst>
-          </p:cNvPr>
-          <p:cNvSpPr/>
-          <p:nvPr/>
-        </p:nvSpPr>
-        <p:spPr>
-          <a:xfrm>
-            <a:off x="9582325" y="4408415"/>
-            <a:ext cx="281031" cy="1103152"/>
-          </a:xfrm>
-          <a:prstGeom prst="rightBrace">
-            <a:avLst/>
-          </a:prstGeom>
-        </p:spPr>
-        <p:style>
-          <a:lnRef idx="2">
-            <a:schemeClr val="accent1"/>
-          </a:lnRef>
-          <a:fillRef idx="0">
-            <a:schemeClr val="accent1"/>
-          </a:fillRef>
-          <a:effectRef idx="1">
-            <a:schemeClr val="accent1"/>
-          </a:effectRef>
-          <a:fontRef idx="minor">
-            <a:schemeClr val="tx1"/>
-          </a:fontRef>
-        </p:style>
-        <p:txBody>
-          <a:bodyPr rtlCol="0" anchor="ctr"/>
-          <a:lstStyle/>
-          <a:p>
-            <a:pPr algn="ctr"/>
-            <a:endParaRPr lang="en-US" dirty="0"/>
-          </a:p>
-        </p:txBody>
-      </p:sp>
-      <p:sp>
-        <p:nvSpPr>
-          <p:cNvPr id="5" name="TextBox 4">
-            <a:extLst>
-              <a:ext uri="{FF2B5EF4-FFF2-40B4-BE49-F238E27FC236}">
-                <a16:creationId xmlns:a16="http://schemas.microsoft.com/office/drawing/2014/main" id="{DC7DAF1B-95EB-22B1-1191-7C8BC9E6FAC3}"/>
-              </a:ext>
-            </a:extLst>
-          </p:cNvPr>
-          <p:cNvSpPr txBox="1"/>
-          <p:nvPr/>
-        </p:nvSpPr>
-        <p:spPr>
-          <a:xfrm>
-            <a:off x="9987094" y="4636825"/>
-            <a:ext cx="1635854" cy="646331"/>
-          </a:xfrm>
-          <a:prstGeom prst="rect">
-            <a:avLst/>
-          </a:prstGeom>
-        </p:spPr>
-        <p:style>
-          <a:lnRef idx="2">
-            <a:schemeClr val="accent1">
-              <a:shade val="15000"/>
-            </a:schemeClr>
-          </a:lnRef>
-          <a:fillRef idx="1">
-            <a:schemeClr val="accent1"/>
-          </a:fillRef>
-          <a:effectRef idx="0">
-            <a:schemeClr val="accent1"/>
-          </a:effectRef>
-          <a:fontRef idx="minor">
-            <a:schemeClr val="lt1"/>
-          </a:fontRef>
-        </p:style>
-        <p:txBody>
-          <a:bodyPr wrap="square" rtlCol="0">
-            <a:spAutoFit/>
-          </a:bodyPr>
-          <a:lstStyle/>
-          <a:p>
-            <a:r>
-              <a:rPr lang="en-US" dirty="0"/>
-              <a:t>Asynchronous DP can help</a:t>
-            </a:r>
-          </a:p>
-        </p:txBody>
-      </p:sp>
     </p:spTree>
     <p:extLst>
       <p:ext uri="{BB962C8B-B14F-4D97-AF65-F5344CB8AC3E}">
-        <p14:creationId xmlns:p14="http://schemas.microsoft.com/office/powerpoint/2010/main" val="2486968449"/>
+        <p14:creationId xmlns:p14="http://schemas.microsoft.com/office/powerpoint/2010/main" val="4156439938"/>
       </p:ext>
     </p:extLst>
   </p:cSld>
@@ -24548,6 +24386,133 @@
 </file>
 
 <file path=ppt/slides/slide25.xml><?xml version="1.0" encoding="utf-8"?>
+<p:sld xmlns:a="http://schemas.openxmlformats.org/drawingml/2006/main" xmlns:r="http://schemas.openxmlformats.org/officeDocument/2006/relationships" xmlns:p="http://schemas.openxmlformats.org/presentationml/2006/main">
+  <p:cSld>
+    <p:spTree>
+      <p:nvGrpSpPr>
+        <p:cNvPr id="1" name="">
+          <a:extLst>
+            <a:ext uri="{FF2B5EF4-FFF2-40B4-BE49-F238E27FC236}">
+              <a16:creationId xmlns:a16="http://schemas.microsoft.com/office/drawing/2014/main" id="{DE2F969D-8D6C-0B24-2FBF-153574A4FA72}"/>
+            </a:ext>
+          </a:extLst>
+        </p:cNvPr>
+        <p:cNvGrpSpPr/>
+        <p:nvPr/>
+      </p:nvGrpSpPr>
+      <p:grpSpPr>
+        <a:xfrm>
+          <a:off x="0" y="0"/>
+          <a:ext cx="0" cy="0"/>
+          <a:chOff x="0" y="0"/>
+          <a:chExt cx="0" cy="0"/>
+        </a:xfrm>
+      </p:grpSpPr>
+      <p:sp>
+        <p:nvSpPr>
+          <p:cNvPr id="4" name="Title 3">
+            <a:extLst>
+              <a:ext uri="{FF2B5EF4-FFF2-40B4-BE49-F238E27FC236}">
+                <a16:creationId xmlns:a16="http://schemas.microsoft.com/office/drawing/2014/main" id="{690557DC-CC55-03B0-D87E-1EBAB8F91AA7}"/>
+              </a:ext>
+            </a:extLst>
+          </p:cNvPr>
+          <p:cNvSpPr>
+            <a:spLocks noGrp="1"/>
+          </p:cNvSpPr>
+          <p:nvPr>
+            <p:ph type="title"/>
+          </p:nvPr>
+        </p:nvSpPr>
+        <p:spPr>
+          <a:xfrm>
+            <a:off x="1105486" y="2766218"/>
+            <a:ext cx="10515600" cy="1168047"/>
+          </a:xfrm>
+        </p:spPr>
+        <p:txBody>
+          <a:bodyPr>
+            <a:normAutofit fontScale="90000"/>
+          </a:bodyPr>
+          <a:lstStyle/>
+          <a:p>
+            <a:r>
+              <a:rPr lang="en-US" b="1" dirty="0"/>
+              <a:t>Code example: </a:t>
+            </a:r>
+            <a:br>
+              <a:rPr lang="en-US" b="1" dirty="0"/>
+            </a:br>
+            <a:r>
+              <a:rPr lang="en-US" dirty="0"/>
+              <a:t>Compare the convergence of Policy Evaluation using different versions of the L-maze</a:t>
+            </a:r>
+            <a:br>
+              <a:rPr lang="en-US" dirty="0"/>
+            </a:br>
+            <a:endParaRPr lang="en-US" dirty="0"/>
+          </a:p>
+        </p:txBody>
+      </p:sp>
+      <p:sp>
+        <p:nvSpPr>
+          <p:cNvPr id="5" name="TextBox 4">
+            <a:extLst>
+              <a:ext uri="{FF2B5EF4-FFF2-40B4-BE49-F238E27FC236}">
+                <a16:creationId xmlns:a16="http://schemas.microsoft.com/office/drawing/2014/main" id="{D51F0114-615F-945E-3B2F-658483E251E4}"/>
+              </a:ext>
+            </a:extLst>
+          </p:cNvPr>
+          <p:cNvSpPr txBox="1"/>
+          <p:nvPr/>
+        </p:nvSpPr>
+        <p:spPr>
+          <a:xfrm>
+            <a:off x="1191065" y="6011594"/>
+            <a:ext cx="8811064" cy="307777"/>
+          </a:xfrm>
+          <a:prstGeom prst="rect">
+            <a:avLst/>
+          </a:prstGeom>
+          <a:noFill/>
+        </p:spPr>
+        <p:txBody>
+          <a:bodyPr wrap="square" rtlCol="0">
+            <a:spAutoFit/>
+          </a:bodyPr>
+          <a:lstStyle/>
+          <a:p>
+            <a:r>
+              <a:rPr lang="en-US" sz="1400" dirty="0"/>
+              <a:t>See Code on </a:t>
+            </a:r>
+            <a:r>
+              <a:rPr lang="en-US" sz="1400" dirty="0">
+                <a:hlinkClick r:id="rId2"/>
+              </a:rPr>
+              <a:t>https://michael.hahsler.net/Introduction_to_Reinforcement_Learning/</a:t>
+            </a:r>
+            <a:r>
+              <a:rPr lang="en-US" sz="1400" dirty="0"/>
+              <a:t> </a:t>
+            </a:r>
+          </a:p>
+        </p:txBody>
+      </p:sp>
+    </p:spTree>
+    <p:extLst>
+      <p:ext uri="{BB962C8B-B14F-4D97-AF65-F5344CB8AC3E}">
+        <p14:creationId xmlns:p14="http://schemas.microsoft.com/office/powerpoint/2010/main" val="2349689889"/>
+      </p:ext>
+    </p:extLst>
+  </p:cSld>
+  <p:clrMapOvr>
+    <a:masterClrMapping/>
+  </p:clrMapOvr>
+</p:sld>
+</file>
+
+<file path=ppt/slides/slide26.xml><?xml version="1.0" encoding="utf-8"?>
 <p:sld xmlns:a="http://schemas.openxmlformats.org/drawingml/2006/main" xmlns:r="http://schemas.openxmlformats.org/officeDocument/2006/relationships" xmlns:p="http://schemas.openxmlformats.org/presentationml/2006/main">
   <p:cSld>
     <p:spTree>
@@ -24587,7 +24552,7 @@
           <a:p>
             <a:r>
               <a:rPr lang="en-US" dirty="0"/>
-              <a:t>Efficiency</a:t>
+              <a:t>Efficiency Comparison</a:t>
             </a:r>
           </a:p>
         </p:txBody>
@@ -25063,7 +25028,458 @@
 </p:sld>
 </file>
 
-<file path=ppt/slides/slide26.xml><?xml version="1.0" encoding="utf-8"?>
+<file path=ppt/slides/slide27.xml><?xml version="1.0" encoding="utf-8"?>
+<p:sld xmlns:a="http://schemas.openxmlformats.org/drawingml/2006/main" xmlns:r="http://schemas.openxmlformats.org/officeDocument/2006/relationships" xmlns:p="http://schemas.openxmlformats.org/presentationml/2006/main">
+  <p:cSld>
+    <p:spTree>
+      <p:nvGrpSpPr>
+        <p:cNvPr id="1" name=""/>
+        <p:cNvGrpSpPr/>
+        <p:nvPr/>
+      </p:nvGrpSpPr>
+      <p:grpSpPr>
+        <a:xfrm>
+          <a:off x="0" y="0"/>
+          <a:ext cx="0" cy="0"/>
+          <a:chOff x="0" y="0"/>
+          <a:chExt cx="0" cy="0"/>
+        </a:xfrm>
+      </p:grpSpPr>
+      <p:sp>
+        <p:nvSpPr>
+          <p:cNvPr id="2" name="Title 1">
+            <a:extLst>
+              <a:ext uri="{FF2B5EF4-FFF2-40B4-BE49-F238E27FC236}">
+                <a16:creationId xmlns:a16="http://schemas.microsoft.com/office/drawing/2014/main" id="{CE64B189-2BE7-EF8E-90AD-B8D2A5B4A30A}"/>
+              </a:ext>
+            </a:extLst>
+          </p:cNvPr>
+          <p:cNvSpPr>
+            <a:spLocks noGrp="1"/>
+          </p:cNvSpPr>
+          <p:nvPr>
+            <p:ph type="title"/>
+          </p:nvPr>
+        </p:nvSpPr>
+        <p:spPr/>
+        <p:txBody>
+          <a:bodyPr/>
+          <a:lstStyle/>
+          <a:p>
+            <a:r>
+              <a:rPr lang="en-US" dirty="0"/>
+              <a:t>Issues with DP Methods</a:t>
+            </a:r>
+          </a:p>
+        </p:txBody>
+      </p:sp>
+      <mc:AlternateContent xmlns:mc="http://schemas.openxmlformats.org/markup-compatibility/2006" xmlns:a14="http://schemas.microsoft.com/office/drawing/2010/main">
+        <mc:Choice Requires="a14">
+          <p:sp>
+            <p:nvSpPr>
+              <p:cNvPr id="3" name="Content Placeholder 2" descr="Require perfect knowledge of the model!. Space Complexity. Tabular method: stores the complete value function as tables V or Q . Time Complexity. Updates repeatedly sweep over the whole state space. Wastes computation by updating states that are not relevant for the optimal behavior. I.e., the optimal policy will never visit them. Tabular methods can not generalize between similar states">
+                <a:extLst>
+                  <a:ext uri="{FF2B5EF4-FFF2-40B4-BE49-F238E27FC236}">
+                    <a16:creationId xmlns:a16="http://schemas.microsoft.com/office/drawing/2014/main" id="{5664E2E2-C328-F2E5-08B7-7436CBE7F52E}"/>
+                  </a:ext>
+                </a:extLst>
+              </p:cNvPr>
+              <p:cNvSpPr>
+                <a:spLocks noGrp="1"/>
+              </p:cNvSpPr>
+              <p:nvPr>
+                <p:ph idx="1"/>
+              </p:nvPr>
+            </p:nvSpPr>
+            <p:spPr>
+              <a:xfrm>
+                <a:off x="838200" y="1397330"/>
+                <a:ext cx="8804945" cy="4779633"/>
+              </a:xfrm>
+            </p:spPr>
+            <p:txBody>
+              <a:bodyPr>
+                <a:normAutofit lnSpcReduction="10000"/>
+              </a:bodyPr>
+              <a:lstStyle/>
+              <a:p>
+                <a:pPr marL="0" indent="0">
+                  <a:buNone/>
+                </a:pPr>
+                <a:r>
+                  <a:rPr lang="en-US" b="1" dirty="0"/>
+                  <a:t>Require perfect knowledge of the model!</a:t>
+                </a:r>
+              </a:p>
+              <a:p>
+                <a:pPr marL="0" indent="0">
+                  <a:buNone/>
+                </a:pPr>
+                <a:endParaRPr lang="en-US" b="1" dirty="0"/>
+              </a:p>
+              <a:p>
+                <a:pPr marL="0" indent="0">
+                  <a:buNone/>
+                </a:pPr>
+                <a:r>
+                  <a:rPr lang="en-US" b="1" dirty="0"/>
+                  <a:t>Space Complexity</a:t>
+                </a:r>
+                <a:endParaRPr lang="en-US" dirty="0"/>
+              </a:p>
+              <a:p>
+                <a:pPr lvl="1"/>
+                <a:r>
+                  <a:rPr lang="en-US" dirty="0"/>
+                  <a:t>Tabular method: stores the complete value function as tables </a:t>
+                </a:r>
+                <a14:m>
+                  <m:oMath xmlns:m="http://schemas.openxmlformats.org/officeDocument/2006/math">
+                    <m:r>
+                      <a:rPr lang="en-US" b="0" i="1" smtClean="0">
+                        <a:latin typeface="Cambria Math" panose="02040503050406030204" pitchFamily="18" charset="0"/>
+                      </a:rPr>
+                      <m:t>𝑉</m:t>
+                    </m:r>
+                  </m:oMath>
+                </a14:m>
+                <a:r>
+                  <a:rPr lang="en-US" dirty="0"/>
+                  <a:t> or </a:t>
+                </a:r>
+                <a14:m>
+                  <m:oMath xmlns:m="http://schemas.openxmlformats.org/officeDocument/2006/math">
+                    <m:r>
+                      <a:rPr lang="en-US" b="0" i="1" smtClean="0">
+                        <a:latin typeface="Cambria Math" panose="02040503050406030204" pitchFamily="18" charset="0"/>
+                      </a:rPr>
+                      <m:t>𝑄</m:t>
+                    </m:r>
+                  </m:oMath>
+                </a14:m>
+                <a:r>
+                  <a:rPr lang="en-US" dirty="0"/>
+                  <a:t>. </a:t>
+                </a:r>
+              </a:p>
+              <a:p>
+                <a:endParaRPr lang="en-US" dirty="0"/>
+              </a:p>
+              <a:p>
+                <a:pPr marL="0" indent="0">
+                  <a:buNone/>
+                </a:pPr>
+                <a:r>
+                  <a:rPr lang="en-US" b="1" dirty="0"/>
+                  <a:t>Time Complexity</a:t>
+                </a:r>
+              </a:p>
+              <a:p>
+                <a:pPr lvl="1"/>
+                <a:r>
+                  <a:rPr lang="en-US" dirty="0"/>
+                  <a:t>Updates repeatedly sweep over the whole state space.</a:t>
+                </a:r>
+              </a:p>
+              <a:p>
+                <a:pPr lvl="1"/>
+                <a:r>
+                  <a:rPr lang="en-US" dirty="0"/>
+                  <a:t>Wastes computation by updating states that are not relevant for the optimal behavior. I.e., the optimal policy will never visit them.</a:t>
+                </a:r>
+              </a:p>
+              <a:p>
+                <a:pPr lvl="1"/>
+                <a:r>
+                  <a:rPr lang="en-US" dirty="0"/>
+                  <a:t>Tabular methods can not generalize between similar states.</a:t>
+                </a:r>
+              </a:p>
+            </p:txBody>
+          </p:sp>
+        </mc:Choice>
+        <mc:Fallback xmlns="">
+          <p:sp>
+            <p:nvSpPr>
+              <p:cNvPr id="3" name="Content Placeholder 2" descr="Require perfect knowledge of the model!. Space Complexity. Tabular method: stores the complete value function as tables V or Q . Time Complexity. Updates repeatedly sweep over the whole state space. Wastes computation by updating states that are not relevant for the optimal behavior. I.e., the optimal policy will never visit them. Tabular methods can not generalize between similar states">
+                <a:extLst>
+                  <a:ext uri="{FF2B5EF4-FFF2-40B4-BE49-F238E27FC236}">
+                    <a16:creationId xmlns:a16="http://schemas.microsoft.com/office/drawing/2014/main" id="{5664E2E2-C328-F2E5-08B7-7436CBE7F52E}"/>
+                  </a:ext>
+                </a:extLst>
+              </p:cNvPr>
+              <p:cNvSpPr>
+                <a:spLocks noGrp="1" noRot="1" noChangeAspect="1" noMove="1" noResize="1" noEditPoints="1" noAdjustHandles="1" noChangeArrowheads="1" noChangeShapeType="1" noTextEdit="1"/>
+              </p:cNvSpPr>
+              <p:nvPr>
+                <p:ph idx="1"/>
+              </p:nvPr>
+            </p:nvSpPr>
+            <p:spPr>
+              <a:xfrm>
+                <a:off x="838200" y="1397330"/>
+                <a:ext cx="8804945" cy="4779633"/>
+              </a:xfrm>
+              <a:blipFill>
+                <a:blip r:embed="rId2"/>
+                <a:stretch>
+                  <a:fillRect l="-1454" t="-2806" r="-1108"/>
+                </a:stretch>
+              </a:blipFill>
+            </p:spPr>
+            <p:txBody>
+              <a:bodyPr/>
+              <a:lstStyle/>
+              <a:p>
+                <a:r>
+                  <a:rPr lang="en-US">
+                    <a:noFill/>
+                  </a:rPr>
+                  <a:t> </a:t>
+                </a:r>
+              </a:p>
+            </p:txBody>
+          </p:sp>
+        </mc:Fallback>
+      </mc:AlternateContent>
+      <p:sp>
+        <p:nvSpPr>
+          <p:cNvPr id="4" name="Right Brace 3">
+            <a:extLst>
+              <a:ext uri="{FF2B5EF4-FFF2-40B4-BE49-F238E27FC236}">
+                <a16:creationId xmlns:a16="http://schemas.microsoft.com/office/drawing/2014/main" id="{6339C8F8-48C4-0C07-3B0E-F41FE0B782D3}"/>
+              </a:ext>
+              <a:ext uri="{C183D7F6-B498-43B3-948B-1728B52AA6E4}">
+                <adec:decorative xmlns:adec="http://schemas.microsoft.com/office/drawing/2017/decorative" val="1"/>
+              </a:ext>
+            </a:extLst>
+          </p:cNvPr>
+          <p:cNvSpPr/>
+          <p:nvPr/>
+        </p:nvSpPr>
+        <p:spPr>
+          <a:xfrm>
+            <a:off x="9582325" y="4408415"/>
+            <a:ext cx="281031" cy="1103152"/>
+          </a:xfrm>
+          <a:prstGeom prst="rightBrace">
+            <a:avLst/>
+          </a:prstGeom>
+        </p:spPr>
+        <p:style>
+          <a:lnRef idx="2">
+            <a:schemeClr val="accent1"/>
+          </a:lnRef>
+          <a:fillRef idx="0">
+            <a:schemeClr val="accent1"/>
+          </a:fillRef>
+          <a:effectRef idx="1">
+            <a:schemeClr val="accent1"/>
+          </a:effectRef>
+          <a:fontRef idx="minor">
+            <a:schemeClr val="tx1"/>
+          </a:fontRef>
+        </p:style>
+        <p:txBody>
+          <a:bodyPr rtlCol="0" anchor="ctr"/>
+          <a:lstStyle/>
+          <a:p>
+            <a:pPr algn="ctr"/>
+            <a:endParaRPr lang="en-US" dirty="0"/>
+          </a:p>
+        </p:txBody>
+      </p:sp>
+      <p:sp>
+        <p:nvSpPr>
+          <p:cNvPr id="5" name="TextBox 4">
+            <a:extLst>
+              <a:ext uri="{FF2B5EF4-FFF2-40B4-BE49-F238E27FC236}">
+                <a16:creationId xmlns:a16="http://schemas.microsoft.com/office/drawing/2014/main" id="{DC7DAF1B-95EB-22B1-1191-7C8BC9E6FAC3}"/>
+              </a:ext>
+            </a:extLst>
+          </p:cNvPr>
+          <p:cNvSpPr txBox="1"/>
+          <p:nvPr/>
+        </p:nvSpPr>
+        <p:spPr>
+          <a:xfrm>
+            <a:off x="9987094" y="4636825"/>
+            <a:ext cx="1635854" cy="646331"/>
+          </a:xfrm>
+          <a:prstGeom prst="rect">
+            <a:avLst/>
+          </a:prstGeom>
+        </p:spPr>
+        <p:style>
+          <a:lnRef idx="2">
+            <a:schemeClr val="accent1">
+              <a:shade val="15000"/>
+            </a:schemeClr>
+          </a:lnRef>
+          <a:fillRef idx="1">
+            <a:schemeClr val="accent1"/>
+          </a:fillRef>
+          <a:effectRef idx="0">
+            <a:schemeClr val="accent1"/>
+          </a:effectRef>
+          <a:fontRef idx="minor">
+            <a:schemeClr val="lt1"/>
+          </a:fontRef>
+        </p:style>
+        <p:txBody>
+          <a:bodyPr wrap="square" rtlCol="0">
+            <a:spAutoFit/>
+          </a:bodyPr>
+          <a:lstStyle/>
+          <a:p>
+            <a:r>
+              <a:rPr lang="en-US" dirty="0"/>
+              <a:t>Asynchronous DP can help</a:t>
+            </a:r>
+          </a:p>
+        </p:txBody>
+      </p:sp>
+    </p:spTree>
+    <p:extLst>
+      <p:ext uri="{BB962C8B-B14F-4D97-AF65-F5344CB8AC3E}">
+        <p14:creationId xmlns:p14="http://schemas.microsoft.com/office/powerpoint/2010/main" val="2486968449"/>
+      </p:ext>
+    </p:extLst>
+  </p:cSld>
+  <p:clrMapOvr>
+    <a:masterClrMapping/>
+  </p:clrMapOvr>
+</p:sld>
+</file>
+
+<file path=ppt/slides/slide28.xml><?xml version="1.0" encoding="utf-8"?>
+<p:sld xmlns:a="http://schemas.openxmlformats.org/drawingml/2006/main" xmlns:r="http://schemas.openxmlformats.org/officeDocument/2006/relationships" xmlns:p="http://schemas.openxmlformats.org/presentationml/2006/main">
+  <p:cSld>
+    <p:spTree>
+      <p:nvGrpSpPr>
+        <p:cNvPr id="1" name="">
+          <a:extLst>
+            <a:ext uri="{FF2B5EF4-FFF2-40B4-BE49-F238E27FC236}">
+              <a16:creationId xmlns:a16="http://schemas.microsoft.com/office/drawing/2014/main" id="{10DC13E8-25A8-57D6-4AD4-1C37C79F0776}"/>
+            </a:ext>
+          </a:extLst>
+        </p:cNvPr>
+        <p:cNvGrpSpPr/>
+        <p:nvPr/>
+      </p:nvGrpSpPr>
+      <p:grpSpPr>
+        <a:xfrm>
+          <a:off x="0" y="0"/>
+          <a:ext cx="0" cy="0"/>
+          <a:chOff x="0" y="0"/>
+          <a:chExt cx="0" cy="0"/>
+        </a:xfrm>
+      </p:grpSpPr>
+      <p:sp>
+        <p:nvSpPr>
+          <p:cNvPr id="4" name="Title 3">
+            <a:extLst>
+              <a:ext uri="{FF2B5EF4-FFF2-40B4-BE49-F238E27FC236}">
+                <a16:creationId xmlns:a16="http://schemas.microsoft.com/office/drawing/2014/main" id="{78DC6B0A-58EE-DD0F-9D88-8F7398E414EF}"/>
+              </a:ext>
+            </a:extLst>
+          </p:cNvPr>
+          <p:cNvSpPr>
+            <a:spLocks noGrp="1"/>
+          </p:cNvSpPr>
+          <p:nvPr>
+            <p:ph type="title"/>
+          </p:nvPr>
+        </p:nvSpPr>
+        <p:spPr>
+          <a:xfrm>
+            <a:off x="1105486" y="2766218"/>
+            <a:ext cx="10515600" cy="1168047"/>
+          </a:xfrm>
+        </p:spPr>
+        <p:txBody>
+          <a:bodyPr>
+            <a:normAutofit fontScale="90000"/>
+          </a:bodyPr>
+          <a:lstStyle/>
+          <a:p>
+            <a:r>
+              <a:rPr lang="en-US" b="1" dirty="0"/>
+              <a:t>Code example: </a:t>
+            </a:r>
+            <a:br>
+              <a:rPr lang="en-US" b="1" dirty="0"/>
+            </a:br>
+            <a:r>
+              <a:rPr lang="en-US" dirty="0"/>
+              <a:t>Modeling Tic-Tac-Toe as an MDP and applying Value Iteration</a:t>
+            </a:r>
+            <a:br>
+              <a:rPr lang="en-US" dirty="0"/>
+            </a:br>
+            <a:endParaRPr lang="en-US" dirty="0"/>
+          </a:p>
+        </p:txBody>
+      </p:sp>
+      <p:sp>
+        <p:nvSpPr>
+          <p:cNvPr id="5" name="TextBox 4">
+            <a:extLst>
+              <a:ext uri="{FF2B5EF4-FFF2-40B4-BE49-F238E27FC236}">
+                <a16:creationId xmlns:a16="http://schemas.microsoft.com/office/drawing/2014/main" id="{3357F363-9177-E385-EF6E-C3DC95694022}"/>
+              </a:ext>
+            </a:extLst>
+          </p:cNvPr>
+          <p:cNvSpPr txBox="1"/>
+          <p:nvPr/>
+        </p:nvSpPr>
+        <p:spPr>
+          <a:xfrm>
+            <a:off x="1191065" y="6011594"/>
+            <a:ext cx="8811064" cy="307777"/>
+          </a:xfrm>
+          <a:prstGeom prst="rect">
+            <a:avLst/>
+          </a:prstGeom>
+          <a:noFill/>
+        </p:spPr>
+        <p:txBody>
+          <a:bodyPr wrap="square" rtlCol="0">
+            <a:spAutoFit/>
+          </a:bodyPr>
+          <a:lstStyle/>
+          <a:p>
+            <a:r>
+              <a:rPr lang="en-US" sz="1400" dirty="0"/>
+              <a:t>See Code on </a:t>
+            </a:r>
+            <a:r>
+              <a:rPr lang="en-US" sz="1400" dirty="0">
+                <a:hlinkClick r:id="rId2"/>
+              </a:rPr>
+              <a:t>https://michael.hahsler.net/Introduction_to_Reinforcement_Learning/</a:t>
+            </a:r>
+            <a:r>
+              <a:rPr lang="en-US" sz="1400" dirty="0"/>
+              <a:t> </a:t>
+            </a:r>
+          </a:p>
+        </p:txBody>
+      </p:sp>
+    </p:spTree>
+    <p:extLst>
+      <p:ext uri="{BB962C8B-B14F-4D97-AF65-F5344CB8AC3E}">
+        <p14:creationId xmlns:p14="http://schemas.microsoft.com/office/powerpoint/2010/main" val="466949983"/>
+      </p:ext>
+    </p:extLst>
+  </p:cSld>
+  <p:clrMapOvr>
+    <a:masterClrMapping/>
+  </p:clrMapOvr>
+</p:sld>
+</file>
+
+<file path=ppt/slides/slide29.xml><?xml version="1.0" encoding="utf-8"?>
 <p:sld xmlns:a="http://schemas.openxmlformats.org/drawingml/2006/main" xmlns:r="http://schemas.openxmlformats.org/officeDocument/2006/relationships" xmlns:p="http://schemas.openxmlformats.org/presentationml/2006/main">
   <p:cSld>
     <p:bg>

</xml_diff>